<commit_message>
Section 2.2: red/grey fill + dotted line at +25 mg on dose-discrepancy density
Positive side switched from blue (#1F78B4) to grey60 to match the red/grey
convention used elsewhere; add a dotted vertical at +25 mg as a visual
reference for the per-25-mg reporting scale.

Co-Authored-By: Claude Opus 4.7 (1M context) <noreply@anthropic.com>
</commit_message>
<xml_diff>
--- a/docs/pptx/auc3/jx-auc3-dose-discrep-hist.pptx
+++ b/docs/pptx/auc3/jx-auc3-dose-discrep-hist.pptx
@@ -10603,7 +10603,7 @@
               </a:pathLst>
             </a:custGeom>
             <a:solidFill>
-              <a:srgbClr val="1F78B4">
+              <a:srgbClr val="999999">
                 <a:alpha val="60000"/>
               </a:srgbClr>
             </a:solidFill>
@@ -13193,7 +13193,50 @@
         </p:sp>
         <p:sp>
           <p:nvSpPr>
-            <p:cNvPr id="30" name="tx30"/>
+            <p:cNvPr id="30" name="pl30"/>
+            <p:cNvSpPr/>
+            <p:nvPr/>
+          </p:nvSpPr>
+          <p:spPr>
+            <a:xfrm>
+              <a:off x="5244885" y="1950672"/>
+              <a:ext cx="0" cy="3699310"/>
+            </a:xfrm>
+            <a:custGeom>
+              <a:avLst/>
+              <a:pathLst>
+                <a:path w="0" h="3699310">
+                  <a:moveTo>
+                    <a:pt x="0" y="3699310"/>
+                  </a:moveTo>
+                  <a:lnTo>
+                    <a:pt x="0" y="0"/>
+                  </a:lnTo>
+                  <a:lnTo>
+                    <a:pt x="0" y="0"/>
+                  </a:lnTo>
+                </a:path>
+              </a:pathLst>
+            </a:custGeom>
+            <a:ln w="13550" cap="flat">
+              <a:solidFill>
+                <a:srgbClr val="4D4D4D">
+                  <a:alpha val="100000"/>
+                </a:srgbClr>
+              </a:solidFill>
+              <a:prstDash val="dot"/>
+              <a:round/>
+            </a:ln>
+          </p:spPr>
+          <p:txBody>
+            <a:bodyPr/>
+            <a:lstStyle/>
+            <a:p/>
+          </p:txBody>
+        </p:sp>
+        <p:sp>
+          <p:nvSpPr>
+            <p:cNvPr id="31" name="tx31"/>
             <p:cNvSpPr/>
             <p:nvPr/>
           </p:nvSpPr>
@@ -13239,7 +13282,7 @@
         </p:sp>
         <p:sp>
           <p:nvSpPr>
-            <p:cNvPr id="31" name="tx31"/>
+            <p:cNvPr id="32" name="tx32"/>
             <p:cNvSpPr/>
             <p:nvPr/>
           </p:nvSpPr>
@@ -13285,7 +13328,7 @@
         </p:sp>
         <p:sp>
           <p:nvSpPr>
-            <p:cNvPr id="32" name="tx32"/>
+            <p:cNvPr id="33" name="tx33"/>
             <p:cNvSpPr/>
             <p:nvPr/>
           </p:nvSpPr>
@@ -13331,7 +13374,7 @@
         </p:sp>
         <p:sp>
           <p:nvSpPr>
-            <p:cNvPr id="33" name="tx33"/>
+            <p:cNvPr id="34" name="tx34"/>
             <p:cNvSpPr/>
             <p:nvPr/>
           </p:nvSpPr>
@@ -13377,7 +13420,7 @@
         </p:sp>
         <p:sp>
           <p:nvSpPr>
-            <p:cNvPr id="34" name="tx34"/>
+            <p:cNvPr id="35" name="tx35"/>
             <p:cNvSpPr/>
             <p:nvPr/>
           </p:nvSpPr>
@@ -13423,7 +13466,7 @@
         </p:sp>
         <p:sp>
           <p:nvSpPr>
-            <p:cNvPr id="35" name="tx35"/>
+            <p:cNvPr id="36" name="tx36"/>
             <p:cNvSpPr/>
             <p:nvPr/>
           </p:nvSpPr>
@@ -13469,7 +13512,7 @@
         </p:sp>
         <p:sp>
           <p:nvSpPr>
-            <p:cNvPr id="36" name="tx36"/>
+            <p:cNvPr id="37" name="tx37"/>
             <p:cNvSpPr/>
             <p:nvPr/>
           </p:nvSpPr>
@@ -13515,7 +13558,7 @@
         </p:sp>
         <p:sp>
           <p:nvSpPr>
-            <p:cNvPr id="37" name="tx37"/>
+            <p:cNvPr id="38" name="tx38"/>
             <p:cNvSpPr/>
             <p:nvPr/>
           </p:nvSpPr>
@@ -13561,7 +13604,7 @@
         </p:sp>
         <p:sp>
           <p:nvSpPr>
-            <p:cNvPr id="38" name="tx38"/>
+            <p:cNvPr id="39" name="tx39"/>
             <p:cNvSpPr/>
             <p:nvPr/>
           </p:nvSpPr>
@@ -13607,7 +13650,7 @@
         </p:sp>
         <p:sp>
           <p:nvSpPr>
-            <p:cNvPr id="39" name="tx39"/>
+            <p:cNvPr id="40" name="tx40"/>
             <p:cNvSpPr/>
             <p:nvPr/>
           </p:nvSpPr>
@@ -13653,7 +13696,7 @@
         </p:sp>
         <p:sp>
           <p:nvSpPr>
-            <p:cNvPr id="40" name="tx40"/>
+            <p:cNvPr id="41" name="tx41"/>
             <p:cNvSpPr/>
             <p:nvPr/>
           </p:nvSpPr>
@@ -13699,7 +13742,7 @@
         </p:sp>
         <p:sp>
           <p:nvSpPr>
-            <p:cNvPr id="41" name="tx41"/>
+            <p:cNvPr id="42" name="tx42"/>
             <p:cNvSpPr/>
             <p:nvPr/>
           </p:nvSpPr>
@@ -13745,7 +13788,7 @@
         </p:sp>
         <p:sp>
           <p:nvSpPr>
-            <p:cNvPr id="42" name="tx42"/>
+            <p:cNvPr id="43" name="tx43"/>
             <p:cNvSpPr/>
             <p:nvPr/>
           </p:nvSpPr>

</xml_diff>